<commit_message>
chore(ppt): showcase slides in the WAC template — one example per layout
The new layouts only lived in the slide master, so the file looked
unchanged when opened. Its slides are now a 14-slide showcase (built with
the deck engine itself, zero warnings); the builder strips template slides
on export, so they're purely documentation.

Co-Authored-By: Claude Fable 5 <noreply@anthropic.com>
</commit_message>
<xml_diff>
--- a/WAC-Group-PPT-Template.pptx
+++ b/WAC-Group-PPT-Template.pptx
@@ -12,6 +12,13 @@
     <p:sldId id="260" r:id="rId10"/>
     <p:sldId id="261" r:id="rId11"/>
     <p:sldId id="262" r:id="rId12"/>
+    <p:sldId id="263" r:id="rId13"/>
+    <p:sldId id="264" r:id="rId14"/>
+    <p:sldId id="265" r:id="rId15"/>
+    <p:sldId id="266" r:id="rId16"/>
+    <p:sldId id="267" r:id="rId17"/>
+    <p:sldId id="268" r:id="rId18"/>
+    <p:sldId id="269" r:id="rId19"/>
   </p:sldIdLst>
   <p:sldSz cx="12192000" cy="6858000"/>
   <p:notesSz cx="6858000" cy="9144000"/>
@@ -29,6 +36,178 @@
     </a:lvl1pPr>
   </p:defaultTextStyle>
 </p:presentation>
+</file>
+
+<file path=ppt/charts/chart1.xml><?xml version="1.0" encoding="utf-8"?>
+<c:chartSpace xmlns:c="http://schemas.openxmlformats.org/drawingml/2006/chart" xmlns:a="http://schemas.openxmlformats.org/drawingml/2006/main" xmlns:r="http://schemas.openxmlformats.org/officeDocument/2006/relationships">
+  <c:date1904 val="0"/>
+  <c:chart>
+    <c:autoTitleDeleted val="0"/>
+    <c:plotArea>
+      <c:barChart>
+        <c:barDir val="col"/>
+        <c:grouping val="clustered"/>
+        <c:ser>
+          <c:idx val="0"/>
+          <c:order val="0"/>
+          <c:tx>
+            <c:strRef>
+              <c:f>Sheet1!$B$1</c:f>
+              <c:strCache>
+                <c:ptCount val="1"/>
+                <c:pt idx="0">
+                  <c:v>2025</c:v>
+                </c:pt>
+              </c:strCache>
+            </c:strRef>
+          </c:tx>
+          <c:cat>
+            <c:strRef>
+              <c:f>Sheet1!$A$2:$A$5</c:f>
+              <c:strCache>
+                <c:ptCount val="4"/>
+                <c:pt idx="0">
+                  <c:v>Q1</c:v>
+                </c:pt>
+                <c:pt idx="1">
+                  <c:v>Q2</c:v>
+                </c:pt>
+                <c:pt idx="2">
+                  <c:v>Q3</c:v>
+                </c:pt>
+                <c:pt idx="3">
+                  <c:v>Q4</c:v>
+                </c:pt>
+              </c:strCache>
+            </c:strRef>
+          </c:cat>
+          <c:val>
+            <c:numRef>
+              <c:f>Sheet1!$B$2:$B$5</c:f>
+              <c:numCache>
+                <c:formatCode>General</c:formatCode>
+                <c:ptCount val="4"/>
+                <c:pt idx="0">
+                  <c:v>12.0</c:v>
+                </c:pt>
+                <c:pt idx="1">
+                  <c:v>18.0</c:v>
+                </c:pt>
+                <c:pt idx="2">
+                  <c:v>15.0</c:v>
+                </c:pt>
+                <c:pt idx="3">
+                  <c:v>22.0</c:v>
+                </c:pt>
+              </c:numCache>
+            </c:numRef>
+          </c:val>
+        </c:ser>
+        <c:ser>
+          <c:idx val="1"/>
+          <c:order val="1"/>
+          <c:tx>
+            <c:strRef>
+              <c:f>Sheet1!$C$1</c:f>
+              <c:strCache>
+                <c:ptCount val="1"/>
+                <c:pt idx="0">
+                  <c:v>2026</c:v>
+                </c:pt>
+              </c:strCache>
+            </c:strRef>
+          </c:tx>
+          <c:cat>
+            <c:strRef>
+              <c:f>Sheet1!$A$2:$A$5</c:f>
+              <c:strCache>
+                <c:ptCount val="4"/>
+                <c:pt idx="0">
+                  <c:v>Q1</c:v>
+                </c:pt>
+                <c:pt idx="1">
+                  <c:v>Q2</c:v>
+                </c:pt>
+                <c:pt idx="2">
+                  <c:v>Q3</c:v>
+                </c:pt>
+                <c:pt idx="3">
+                  <c:v>Q4</c:v>
+                </c:pt>
+              </c:strCache>
+            </c:strRef>
+          </c:cat>
+          <c:val>
+            <c:numRef>
+              <c:f>Sheet1!$C$2:$C$5</c:f>
+              <c:numCache>
+                <c:formatCode>General</c:formatCode>
+                <c:ptCount val="4"/>
+                <c:pt idx="0">
+                  <c:v>16.0</c:v>
+                </c:pt>
+                <c:pt idx="1">
+                  <c:v>21.0</c:v>
+                </c:pt>
+                <c:pt idx="2">
+                  <c:v>19.0</c:v>
+                </c:pt>
+                <c:pt idx="3">
+                  <c:v>28.0</c:v>
+                </c:pt>
+              </c:numCache>
+            </c:numRef>
+          </c:val>
+        </c:ser>
+        <c:axId val="-2068027336"/>
+        <c:axId val="-2113994440"/>
+      </c:barChart>
+      <c:catAx>
+        <c:axId val="-2068027336"/>
+        <c:scaling>
+          <c:orientation val="minMax"/>
+        </c:scaling>
+        <c:delete val="0"/>
+        <c:axPos val="b"/>
+        <c:majorTickMark val="out"/>
+        <c:minorTickMark val="none"/>
+        <c:tickLblPos val="nextTo"/>
+        <c:crossAx val="-2113994440"/>
+        <c:crosses val="autoZero"/>
+        <c:auto val="1"/>
+        <c:lblAlgn val="ctr"/>
+        <c:lblOffset val="100"/>
+        <c:noMultiLvlLbl val="0"/>
+      </c:catAx>
+      <c:valAx>
+        <c:axId val="-2113994440"/>
+        <c:scaling/>
+        <c:delete val="0"/>
+        <c:axPos val="l"/>
+        <c:majorGridlines/>
+        <c:majorTickMark val="out"/>
+        <c:minorTickMark val="none"/>
+        <c:tickLblPos val="nextTo"/>
+        <c:crossAx val="-2068027336"/>
+        <c:crosses val="autoZero"/>
+      </c:valAx>
+    </c:plotArea>
+    <c:dispBlanksAs val="gap"/>
+  </c:chart>
+  <c:txPr>
+    <a:bodyPr/>
+    <a:lstStyle/>
+    <a:p>
+      <a:pPr>
+        <a:defRPr sz="1800"/>
+      </a:pPr>
+      <a:endParaRPr lang="en-US"/>
+    </a:p>
+  </c:txPr>
+  <c:externalData r:id="rId1">
+    <c:autoUpdate val="0"/>
+  </c:externalData>
+</c:chartSpace>
 </file>
 
 <file path=ppt/slideLayouts/slideLayout1.xml><?xml version="1.0" encoding="utf-8"?>
@@ -1888,7 +2067,7 @@
           <a:lstStyle/>
           <a:p>
             <a:r>
-              <a:t>Technology Illuminated</a:t>
+              <a:t>WAC Group Template</a:t>
             </a:r>
           </a:p>
         </p:txBody>
@@ -1909,11 +2088,849 @@
           <a:lstStyle/>
           <a:p>
             <a:r>
-              <a:t>WAC Group Presentation Template</a:t>
-            </a:r>
-          </a:p>
-        </p:txBody>
-      </p:sp>
+              <a:t>One example slide per layout — replace or delete freely</a:t>
+            </a:r>
+          </a:p>
+        </p:txBody>
+      </p:sp>
+    </p:spTree>
+  </p:cSld>
+  <p:clrMapOvr>
+    <a:masterClrMapping/>
+  </p:clrMapOvr>
+</p:sld>
+</file>
+
+<file path=ppt/slides/slide10.xml><?xml version="1.0" encoding="utf-8"?>
+<p:sld xmlns:a="http://schemas.openxmlformats.org/drawingml/2006/main" xmlns:p="http://schemas.openxmlformats.org/presentationml/2006/main" xmlns:r="http://schemas.openxmlformats.org/officeDocument/2006/relationships">
+  <p:cSld>
+    <p:spTree>
+      <p:nvGrpSpPr>
+        <p:cNvPr id="1" name=""/>
+        <p:cNvGrpSpPr/>
+        <p:nvPr/>
+      </p:nvGrpSpPr>
+      <p:grpSpPr/>
+      <p:sp>
+        <p:nvSpPr>
+          <p:cNvPr id="2" name="Title 1"/>
+          <p:cNvSpPr>
+            <a:spLocks noGrp="1"/>
+          </p:cNvSpPr>
+          <p:nvPr>
+            <p:ph type="title"/>
+          </p:nvPr>
+        </p:nvSpPr>
+        <p:spPr/>
+        <p:txBody>
+          <a:bodyPr/>
+          <a:lstStyle/>
+          <a:p>
+            <a:r>
+              <a:t>Chart</a:t>
+            </a:r>
+          </a:p>
+        </p:txBody>
+      </p:sp>
+      <p:sp>
+        <p:nvSpPr>
+          <p:cNvPr id="3" name="Text Placeholder 2"/>
+          <p:cNvSpPr>
+            <a:spLocks noGrp="1"/>
+          </p:cNvSpPr>
+          <p:nvPr>
+            <p:ph type="body" idx="1"/>
+          </p:nvPr>
+        </p:nvSpPr>
+        <p:spPr/>
+        <p:txBody>
+          <a:bodyPr/>
+          <a:lstStyle/>
+          <a:p/>
+        </p:txBody>
+      </p:sp>
+      <p:graphicFrame>
+        <p:nvGraphicFramePr>
+          <p:cNvPr id="4" name="Chart 3"/>
+          <p:cNvGraphicFramePr>
+            <a:graphicFrameLocks noGrp="1"/>
+          </p:cNvGraphicFramePr>
+          <p:nvPr/>
+        </p:nvGraphicFramePr>
+        <p:xfrm>
+          <a:off x="548640" y="1600200"/>
+          <a:ext cx="11094720" cy="4457700"/>
+        </p:xfrm>
+        <a:graphic>
+          <a:graphicData uri="http://schemas.openxmlformats.org/drawingml/2006/chart">
+            <c:chart xmlns:c="http://schemas.openxmlformats.org/drawingml/2006/chart" r:id="rId2"/>
+          </a:graphicData>
+        </a:graphic>
+      </p:graphicFrame>
+    </p:spTree>
+  </p:cSld>
+  <p:clrMapOvr>
+    <a:masterClrMapping/>
+  </p:clrMapOvr>
+</p:sld>
+</file>
+
+<file path=ppt/slides/slide11.xml><?xml version="1.0" encoding="utf-8"?>
+<p:sld xmlns:a="http://schemas.openxmlformats.org/drawingml/2006/main" xmlns:p="http://schemas.openxmlformats.org/presentationml/2006/main" xmlns:r="http://schemas.openxmlformats.org/officeDocument/2006/relationships">
+  <p:cSld>
+    <p:spTree>
+      <p:nvGrpSpPr>
+        <p:cNvPr id="1" name=""/>
+        <p:cNvGrpSpPr/>
+        <p:nvPr/>
+      </p:nvGrpSpPr>
+      <p:grpSpPr/>
+      <p:sp>
+        <p:nvSpPr>
+          <p:cNvPr id="2" name="Title 1"/>
+          <p:cNvSpPr>
+            <a:spLocks noGrp="1"/>
+          </p:cNvSpPr>
+          <p:nvPr>
+            <p:ph type="title"/>
+          </p:nvPr>
+        </p:nvSpPr>
+        <p:spPr/>
+        <p:txBody>
+          <a:bodyPr/>
+          <a:lstStyle/>
+          <a:p>
+            <a:r>
+              <a:t>Diagram</a:t>
+            </a:r>
+          </a:p>
+        </p:txBody>
+      </p:sp>
+      <p:sp>
+        <p:nvSpPr>
+          <p:cNvPr id="3" name="Text Placeholder 2"/>
+          <p:cNvSpPr>
+            <a:spLocks noGrp="1"/>
+          </p:cNvSpPr>
+          <p:nvPr>
+            <p:ph type="body" idx="1"/>
+          </p:nvPr>
+        </p:nvSpPr>
+        <p:spPr/>
+        <p:txBody>
+          <a:bodyPr/>
+          <a:lstStyle/>
+          <a:p/>
+        </p:txBody>
+      </p:sp>
+      <p:sp>
+        <p:nvSpPr>
+          <p:cNvPr id="4" name="Rounded Rectangle 3"/>
+          <p:cNvSpPr/>
+          <p:nvPr/>
+        </p:nvSpPr>
+        <p:spPr>
+          <a:xfrm>
+            <a:off x="548640" y="1600200"/>
+            <a:ext cx="3328416" cy="2050542"/>
+          </a:xfrm>
+          <a:prstGeom prst="roundRect">
+            <a:avLst/>
+          </a:prstGeom>
+          <a:solidFill>
+            <a:schemeClr val="accent1"/>
+          </a:solidFill>
+        </p:spPr>
+        <p:style>
+          <a:lnRef idx="1">
+            <a:schemeClr val="accent1"/>
+          </a:lnRef>
+          <a:fillRef idx="3">
+            <a:schemeClr val="accent1"/>
+          </a:fillRef>
+          <a:effectRef idx="2">
+            <a:schemeClr val="accent1"/>
+          </a:effectRef>
+          <a:fontRef idx="minor">
+            <a:schemeClr val="lt1"/>
+          </a:fontRef>
+        </p:style>
+        <p:txBody>
+          <a:bodyPr rtlCol="0" anchor="ctr" wrap="square"/>
+          <a:lstStyle/>
+          <a:p>
+            <a:r>
+              <a:t>Residential</a:t>
+            </a:r>
+          </a:p>
+        </p:txBody>
+      </p:sp>
+      <p:sp>
+        <p:nvSpPr>
+          <p:cNvPr id="5" name="Rounded Rectangle 4"/>
+          <p:cNvSpPr/>
+          <p:nvPr/>
+        </p:nvSpPr>
+        <p:spPr>
+          <a:xfrm>
+            <a:off x="4431792" y="1600200"/>
+            <a:ext cx="3328416" cy="2050542"/>
+          </a:xfrm>
+          <a:prstGeom prst="roundRect">
+            <a:avLst/>
+          </a:prstGeom>
+          <a:solidFill>
+            <a:schemeClr val="accent1"/>
+          </a:solidFill>
+        </p:spPr>
+        <p:style>
+          <a:lnRef idx="1">
+            <a:schemeClr val="accent1"/>
+          </a:lnRef>
+          <a:fillRef idx="3">
+            <a:schemeClr val="accent1"/>
+          </a:fillRef>
+          <a:effectRef idx="2">
+            <a:schemeClr val="accent1"/>
+          </a:effectRef>
+          <a:fontRef idx="minor">
+            <a:schemeClr val="lt1"/>
+          </a:fontRef>
+        </p:style>
+        <p:txBody>
+          <a:bodyPr rtlCol="0" anchor="ctr" wrap="square"/>
+          <a:lstStyle/>
+          <a:p>
+            <a:r>
+              <a:t>Commercial</a:t>
+            </a:r>
+          </a:p>
+        </p:txBody>
+      </p:sp>
+      <p:sp>
+        <p:nvSpPr>
+          <p:cNvPr id="6" name="Rounded Rectangle 5"/>
+          <p:cNvSpPr/>
+          <p:nvPr/>
+        </p:nvSpPr>
+        <p:spPr>
+          <a:xfrm>
+            <a:off x="8314944" y="1600200"/>
+            <a:ext cx="3328416" cy="2050542"/>
+          </a:xfrm>
+          <a:prstGeom prst="roundRect">
+            <a:avLst/>
+          </a:prstGeom>
+          <a:solidFill>
+            <a:schemeClr val="accent1"/>
+          </a:solidFill>
+        </p:spPr>
+        <p:style>
+          <a:lnRef idx="1">
+            <a:schemeClr val="accent1"/>
+          </a:lnRef>
+          <a:fillRef idx="3">
+            <a:schemeClr val="accent1"/>
+          </a:fillRef>
+          <a:effectRef idx="2">
+            <a:schemeClr val="accent1"/>
+          </a:effectRef>
+          <a:fontRef idx="minor">
+            <a:schemeClr val="lt1"/>
+          </a:fontRef>
+        </p:style>
+        <p:txBody>
+          <a:bodyPr rtlCol="0" anchor="ctr" wrap="square"/>
+          <a:lstStyle/>
+          <a:p>
+            <a:r>
+              <a:t>Hospitality</a:t>
+            </a:r>
+          </a:p>
+        </p:txBody>
+      </p:sp>
+      <p:sp>
+        <p:nvSpPr>
+          <p:cNvPr id="7" name="Rounded Rectangle 6"/>
+          <p:cNvSpPr/>
+          <p:nvPr/>
+        </p:nvSpPr>
+        <p:spPr>
+          <a:xfrm>
+            <a:off x="4431792" y="4007358"/>
+            <a:ext cx="3328416" cy="2050542"/>
+          </a:xfrm>
+          <a:prstGeom prst="roundRect">
+            <a:avLst/>
+          </a:prstGeom>
+          <a:solidFill>
+            <a:schemeClr val="accent1"/>
+          </a:solidFill>
+        </p:spPr>
+        <p:style>
+          <a:lnRef idx="1">
+            <a:schemeClr val="accent1"/>
+          </a:lnRef>
+          <a:fillRef idx="3">
+            <a:schemeClr val="accent1"/>
+          </a:fillRef>
+          <a:effectRef idx="2">
+            <a:schemeClr val="accent1"/>
+          </a:effectRef>
+          <a:fontRef idx="minor">
+            <a:schemeClr val="lt1"/>
+          </a:fontRef>
+        </p:style>
+        <p:txBody>
+          <a:bodyPr rtlCol="0" anchor="ctr" wrap="square"/>
+          <a:lstStyle/>
+          <a:p>
+            <a:r>
+              <a:t>Landscape</a:t>
+            </a:r>
+          </a:p>
+        </p:txBody>
+      </p:sp>
+    </p:spTree>
+  </p:cSld>
+  <p:clrMapOvr>
+    <a:masterClrMapping/>
+  </p:clrMapOvr>
+</p:sld>
+</file>
+
+<file path=ppt/slides/slide12.xml><?xml version="1.0" encoding="utf-8"?>
+<p:sld xmlns:a="http://schemas.openxmlformats.org/drawingml/2006/main" xmlns:p="http://schemas.openxmlformats.org/presentationml/2006/main" xmlns:r="http://schemas.openxmlformats.org/officeDocument/2006/relationships">
+  <p:cSld>
+    <p:spTree>
+      <p:nvGrpSpPr>
+        <p:cNvPr id="1" name=""/>
+        <p:cNvGrpSpPr/>
+        <p:nvPr/>
+      </p:nvGrpSpPr>
+      <p:grpSpPr/>
+      <p:sp>
+        <p:nvSpPr>
+          <p:cNvPr id="2" name="Title 1"/>
+          <p:cNvSpPr>
+            <a:spLocks noGrp="1"/>
+          </p:cNvSpPr>
+          <p:nvPr>
+            <p:ph type="title"/>
+          </p:nvPr>
+        </p:nvSpPr>
+        <p:spPr/>
+        <p:txBody>
+          <a:bodyPr/>
+          <a:lstStyle/>
+          <a:p>
+            <a:r>
+              <a:t>Process Flow</a:t>
+            </a:r>
+          </a:p>
+        </p:txBody>
+      </p:sp>
+      <p:sp>
+        <p:nvSpPr>
+          <p:cNvPr id="3" name="Text Placeholder 2"/>
+          <p:cNvSpPr>
+            <a:spLocks noGrp="1"/>
+          </p:cNvSpPr>
+          <p:nvPr>
+            <p:ph type="body" idx="1"/>
+          </p:nvPr>
+        </p:nvSpPr>
+        <p:spPr/>
+        <p:txBody>
+          <a:bodyPr/>
+          <a:lstStyle/>
+          <a:p/>
+        </p:txBody>
+      </p:sp>
+      <p:sp>
+        <p:nvSpPr>
+          <p:cNvPr id="4" name="Pentagon 3"/>
+          <p:cNvSpPr/>
+          <p:nvPr/>
+        </p:nvSpPr>
+        <p:spPr>
+          <a:xfrm>
+            <a:off x="548640" y="3143250"/>
+            <a:ext cx="2607259" cy="1371600"/>
+          </a:xfrm>
+          <a:prstGeom prst="homePlate">
+            <a:avLst/>
+          </a:prstGeom>
+          <a:solidFill>
+            <a:schemeClr val="accent1"/>
+          </a:solidFill>
+        </p:spPr>
+        <p:style>
+          <a:lnRef idx="1">
+            <a:schemeClr val="accent1"/>
+          </a:lnRef>
+          <a:fillRef idx="3">
+            <a:schemeClr val="accent1"/>
+          </a:fillRef>
+          <a:effectRef idx="2">
+            <a:schemeClr val="accent1"/>
+          </a:effectRef>
+          <a:fontRef idx="minor">
+            <a:schemeClr val="lt1"/>
+          </a:fontRef>
+        </p:style>
+        <p:txBody>
+          <a:bodyPr rtlCol="0" anchor="ctr" wrap="square"/>
+          <a:lstStyle/>
+          <a:p>
+            <a:r>
+              <a:t>Specify</a:t>
+            </a:r>
+          </a:p>
+        </p:txBody>
+      </p:sp>
+      <p:sp>
+        <p:nvSpPr>
+          <p:cNvPr id="5" name="Chevron 4"/>
+          <p:cNvSpPr/>
+          <p:nvPr/>
+        </p:nvSpPr>
+        <p:spPr>
+          <a:xfrm>
+            <a:off x="3377793" y="3143250"/>
+            <a:ext cx="2607259" cy="1371600"/>
+          </a:xfrm>
+          <a:prstGeom prst="chevron">
+            <a:avLst/>
+          </a:prstGeom>
+          <a:solidFill>
+            <a:schemeClr val="accent1"/>
+          </a:solidFill>
+        </p:spPr>
+        <p:style>
+          <a:lnRef idx="1">
+            <a:schemeClr val="accent1"/>
+          </a:lnRef>
+          <a:fillRef idx="3">
+            <a:schemeClr val="accent1"/>
+          </a:fillRef>
+          <a:effectRef idx="2">
+            <a:schemeClr val="accent1"/>
+          </a:effectRef>
+          <a:fontRef idx="minor">
+            <a:schemeClr val="lt1"/>
+          </a:fontRef>
+        </p:style>
+        <p:txBody>
+          <a:bodyPr rtlCol="0" anchor="ctr" wrap="square"/>
+          <a:lstStyle/>
+          <a:p>
+            <a:r>
+              <a:t>Order</a:t>
+            </a:r>
+          </a:p>
+        </p:txBody>
+      </p:sp>
+      <p:sp>
+        <p:nvSpPr>
+          <p:cNvPr id="6" name="Chevron 5"/>
+          <p:cNvSpPr/>
+          <p:nvPr/>
+        </p:nvSpPr>
+        <p:spPr>
+          <a:xfrm>
+            <a:off x="6206946" y="3143250"/>
+            <a:ext cx="2607259" cy="1371600"/>
+          </a:xfrm>
+          <a:prstGeom prst="chevron">
+            <a:avLst/>
+          </a:prstGeom>
+          <a:solidFill>
+            <a:schemeClr val="accent1"/>
+          </a:solidFill>
+        </p:spPr>
+        <p:style>
+          <a:lnRef idx="1">
+            <a:schemeClr val="accent1"/>
+          </a:lnRef>
+          <a:fillRef idx="3">
+            <a:schemeClr val="accent1"/>
+          </a:fillRef>
+          <a:effectRef idx="2">
+            <a:schemeClr val="accent1"/>
+          </a:effectRef>
+          <a:fontRef idx="minor">
+            <a:schemeClr val="lt1"/>
+          </a:fontRef>
+        </p:style>
+        <p:txBody>
+          <a:bodyPr rtlCol="0" anchor="ctr" wrap="square"/>
+          <a:lstStyle/>
+          <a:p>
+            <a:r>
+              <a:t>Deliver</a:t>
+            </a:r>
+          </a:p>
+        </p:txBody>
+      </p:sp>
+      <p:sp>
+        <p:nvSpPr>
+          <p:cNvPr id="7" name="Chevron 6"/>
+          <p:cNvSpPr/>
+          <p:nvPr/>
+        </p:nvSpPr>
+        <p:spPr>
+          <a:xfrm>
+            <a:off x="9036099" y="3143250"/>
+            <a:ext cx="2607259" cy="1371600"/>
+          </a:xfrm>
+          <a:prstGeom prst="chevron">
+            <a:avLst/>
+          </a:prstGeom>
+          <a:solidFill>
+            <a:schemeClr val="accent1"/>
+          </a:solidFill>
+        </p:spPr>
+        <p:style>
+          <a:lnRef idx="1">
+            <a:schemeClr val="accent1"/>
+          </a:lnRef>
+          <a:fillRef idx="3">
+            <a:schemeClr val="accent1"/>
+          </a:fillRef>
+          <a:effectRef idx="2">
+            <a:schemeClr val="accent1"/>
+          </a:effectRef>
+          <a:fontRef idx="minor">
+            <a:schemeClr val="lt1"/>
+          </a:fontRef>
+        </p:style>
+        <p:txBody>
+          <a:bodyPr rtlCol="0" anchor="ctr" wrap="square"/>
+          <a:lstStyle/>
+          <a:p>
+            <a:r>
+              <a:t>Install</a:t>
+            </a:r>
+          </a:p>
+        </p:txBody>
+      </p:sp>
+    </p:spTree>
+  </p:cSld>
+  <p:clrMapOvr>
+    <a:masterClrMapping/>
+  </p:clrMapOvr>
+</p:sld>
+</file>
+
+<file path=ppt/slides/slide13.xml><?xml version="1.0" encoding="utf-8"?>
+<p:sld xmlns:a="http://schemas.openxmlformats.org/drawingml/2006/main" xmlns:p="http://schemas.openxmlformats.org/presentationml/2006/main" xmlns:r="http://schemas.openxmlformats.org/officeDocument/2006/relationships">
+  <p:cSld>
+    <p:spTree>
+      <p:nvGrpSpPr>
+        <p:cNvPr id="1" name=""/>
+        <p:cNvGrpSpPr/>
+        <p:nvPr/>
+      </p:nvGrpSpPr>
+      <p:grpSpPr/>
+      <p:sp>
+        <p:nvSpPr>
+          <p:cNvPr id="2" name="Title 1"/>
+          <p:cNvSpPr>
+            <a:spLocks noGrp="1"/>
+          </p:cNvSpPr>
+          <p:nvPr>
+            <p:ph type="title"/>
+          </p:nvPr>
+        </p:nvSpPr>
+        <p:spPr/>
+        <p:txBody>
+          <a:bodyPr/>
+          <a:lstStyle/>
+          <a:p>
+            <a:r>
+              <a:t>Video</a:t>
+            </a:r>
+          </a:p>
+        </p:txBody>
+      </p:sp>
+      <p:sp>
+        <p:nvSpPr>
+          <p:cNvPr id="3" name="Picture Placeholder 2"/>
+          <p:cNvSpPr>
+            <a:spLocks noGrp="1"/>
+          </p:cNvSpPr>
+          <p:nvPr>
+            <p:ph type="pic" idx="1"/>
+          </p:nvPr>
+        </p:nvSpPr>
+        <p:spPr/>
+      </p:sp>
+      <p:pic>
+        <p:nvPicPr>
+          <p:cNvPr id="4" name="v.mp4">
+            <a:hlinkClick r:id="" action="ppaction://media"/>
+          </p:cNvPr>
+          <p:cNvPicPr>
+            <a:picLocks noChangeAspect="1"/>
+          </p:cNvPicPr>
+          <p:nvPr>
+            <a:videoFile r:link="rId3"/>
+            <p:extLst>
+              <p:ext uri="{DAA4B4D4-6D71-4841-9C94-3DE7FCFB9230}">
+                <p14:media xmlns:p14="http://schemas.microsoft.com/office/powerpoint/2010/main" r:embed="rId2"/>
+              </p:ext>
+            </p:extLst>
+          </p:nvPr>
+        </p:nvPicPr>
+        <p:blipFill>
+          <a:blip r:embed="rId4"/>
+          <a:stretch>
+            <a:fillRect/>
+          </a:stretch>
+        </p:blipFill>
+        <p:spPr>
+          <a:xfrm>
+            <a:off x="1828800" y="1600200"/>
+            <a:ext cx="8534400" cy="4800600"/>
+          </a:xfrm>
+          <a:prstGeom prst="rect">
+            <a:avLst/>
+          </a:prstGeom>
+        </p:spPr>
+      </p:pic>
+      <p:sp>
+        <p:nvSpPr>
+          <p:cNvPr id="5" name="TextBox 4"/>
+          <p:cNvSpPr txBox="1"/>
+          <p:nvPr/>
+        </p:nvSpPr>
+        <p:spPr>
+          <a:xfrm>
+            <a:off x="1828800" y="6309360"/>
+            <a:ext cx="8534400" cy="480060"/>
+          </a:xfrm>
+          <a:prstGeom prst="rect">
+            <a:avLst/>
+          </a:prstGeom>
+          <a:noFill/>
+        </p:spPr>
+        <p:txBody>
+          <a:bodyPr wrap="square">
+            <a:spAutoFit/>
+          </a:bodyPr>
+          <a:lstStyle/>
+          <a:p>
+            <a:r>
+              <a:t>Embedded movie file</a:t>
+            </a:r>
+          </a:p>
+        </p:txBody>
+      </p:sp>
+    </p:spTree>
+  </p:cSld>
+  <p:clrMapOvr>
+    <a:masterClrMapping/>
+  </p:clrMapOvr>
+  <p:timing>
+    <p:tnLst>
+      <p:par>
+        <p:cTn id="1" dur="indefinite" restart="never" nodeType="tmRoot">
+          <p:childTnLst>
+            <p:video>
+              <p:cMediaNode vol="80000">
+                <p:cTn id="2" fill="hold" display="0">
+                  <p:stCondLst>
+                    <p:cond delay="indefinite"/>
+                  </p:stCondLst>
+                </p:cTn>
+                <p:tgtEl>
+                  <p:spTgt spid="4"/>
+                </p:tgtEl>
+              </p:cMediaNode>
+            </p:video>
+          </p:childTnLst>
+        </p:cTn>
+      </p:par>
+    </p:tnLst>
+  </p:timing>
+</p:sld>
+</file>
+
+<file path=ppt/slides/slide14.xml><?xml version="1.0" encoding="utf-8"?>
+<p:sld xmlns:a="http://schemas.openxmlformats.org/drawingml/2006/main" xmlns:p="http://schemas.openxmlformats.org/presentationml/2006/main" xmlns:r="http://schemas.openxmlformats.org/officeDocument/2006/relationships">
+  <p:cSld>
+    <p:spTree>
+      <p:nvGrpSpPr>
+        <p:cNvPr id="1" name=""/>
+        <p:cNvGrpSpPr/>
+        <p:nvPr/>
+      </p:nvGrpSpPr>
+      <p:grpSpPr/>
+      <p:sp>
+        <p:nvSpPr>
+          <p:cNvPr id="2" name="Title 1"/>
+          <p:cNvSpPr>
+            <a:spLocks noGrp="1"/>
+          </p:cNvSpPr>
+          <p:nvPr>
+            <p:ph type="title"/>
+          </p:nvPr>
+        </p:nvSpPr>
+        <p:spPr/>
+        <p:txBody>
+          <a:bodyPr/>
+          <a:lstStyle/>
+          <a:p>
+            <a:r>
+              <a:t>Table</a:t>
+            </a:r>
+          </a:p>
+        </p:txBody>
+      </p:sp>
+      <p:graphicFrame>
+        <p:nvGraphicFramePr>
+          <p:cNvPr id="3" name="Table Placeholder 2"/>
+          <p:cNvGraphicFramePr>
+            <a:graphicFrameLocks noGrp="1"/>
+          </p:cNvGraphicFramePr>
+          <p:nvPr>
+            <p:ph type="tbl" idx="1"/>
+          </p:nvPr>
+        </p:nvGraphicFramePr>
+        <p:xfrm>
+          <a:off x="548640" y="1600200"/>
+          <a:ext cx="11094720" cy="1112520"/>
+        </p:xfrm>
+        <a:graphic>
+          <a:graphicData uri="http://schemas.openxmlformats.org/drawingml/2006/table">
+            <a:tbl>
+              <a:tblPr firstRow="1" bandRow="1">
+                <a:tableStyleId>{5C22544A-7EE6-4342-B048-85BDC9FD1C3A}</a:tableStyleId>
+              </a:tblPr>
+              <a:tblGrid>
+                <a:gridCol w="3698240"/>
+                <a:gridCol w="3698240"/>
+                <a:gridCol w="3698240"/>
+              </a:tblGrid>
+              <a:tr h="370840">
+                <a:tc>
+                  <a:txBody>
+                    <a:bodyPr/>
+                    <a:lstStyle/>
+                    <a:p>
+                      <a:r>
+                        <a:t>SKU</a:t>
+                      </a:r>
+                    </a:p>
+                  </a:txBody>
+                  <a:tcPr/>
+                </a:tc>
+                <a:tc>
+                  <a:txBody>
+                    <a:bodyPr/>
+                    <a:lstStyle/>
+                    <a:p>
+                      <a:r>
+                        <a:t>CCT</a:t>
+                      </a:r>
+                    </a:p>
+                  </a:txBody>
+                  <a:tcPr/>
+                </a:tc>
+                <a:tc>
+                  <a:txBody>
+                    <a:bodyPr/>
+                    <a:lstStyle/>
+                    <a:p>
+                      <a:r>
+                        <a:t>Lumens</a:t>
+                      </a:r>
+                    </a:p>
+                  </a:txBody>
+                  <a:tcPr/>
+                </a:tc>
+              </a:tr>
+              <a:tr h="370840">
+                <a:tc>
+                  <a:txBody>
+                    <a:bodyPr/>
+                    <a:lstStyle/>
+                    <a:p>
+                      <a:r>
+                        <a:t>WS-101</a:t>
+                      </a:r>
+                    </a:p>
+                  </a:txBody>
+                  <a:tcPr/>
+                </a:tc>
+                <a:tc>
+                  <a:txBody>
+                    <a:bodyPr/>
+                    <a:lstStyle/>
+                    <a:p>
+                      <a:r>
+                        <a:t>3000K</a:t>
+                      </a:r>
+                    </a:p>
+                  </a:txBody>
+                  <a:tcPr/>
+                </a:tc>
+                <a:tc>
+                  <a:txBody>
+                    <a:bodyPr/>
+                    <a:lstStyle/>
+                    <a:p>
+                      <a:r>
+                        <a:t>1200</a:t>
+                      </a:r>
+                    </a:p>
+                  </a:txBody>
+                  <a:tcPr/>
+                </a:tc>
+              </a:tr>
+              <a:tr h="370840">
+                <a:tc>
+                  <a:txBody>
+                    <a:bodyPr/>
+                    <a:lstStyle/>
+                    <a:p>
+                      <a:r>
+                        <a:t>WS-202</a:t>
+                      </a:r>
+                    </a:p>
+                  </a:txBody>
+                  <a:tcPr/>
+                </a:tc>
+                <a:tc>
+                  <a:txBody>
+                    <a:bodyPr/>
+                    <a:lstStyle/>
+                    <a:p>
+                      <a:r>
+                        <a:t>2700K</a:t>
+                      </a:r>
+                    </a:p>
+                  </a:txBody>
+                  <a:tcPr/>
+                </a:tc>
+                <a:tc>
+                  <a:txBody>
+                    <a:bodyPr/>
+                    <a:lstStyle/>
+                    <a:p>
+                      <a:r>
+                        <a:t>950</a:t>
+                      </a:r>
+                    </a:p>
+                  </a:txBody>
+                  <a:tcPr/>
+                </a:tc>
+              </a:tr>
+            </a:tbl>
+          </a:graphicData>
+        </a:graphic>
+      </p:graphicFrame>
     </p:spTree>
   </p:cSld>
   <p:clrMapOvr>
@@ -1948,7 +2965,47 @@
           <a:lstStyle/>
           <a:p>
             <a:r>
-              <a:t>One Vision. Four Brands.</a:t>
+              <a:t>Agenda</a:t>
+            </a:r>
+          </a:p>
+        </p:txBody>
+      </p:sp>
+      <p:sp>
+        <p:nvSpPr>
+          <p:cNvPr id="3" name="Text Placeholder 2"/>
+          <p:cNvSpPr>
+            <a:spLocks noGrp="1"/>
+          </p:cNvSpPr>
+          <p:nvPr>
+            <p:ph type="body" idx="1"/>
+          </p:nvPr>
+        </p:nvSpPr>
+        <p:spPr/>
+        <p:txBody>
+          <a:bodyPr/>
+          <a:lstStyle/>
+          <a:p>
+            <a:pPr>
+              <a:buAutoNum type="arabicPeriod"/>
+            </a:pPr>
+            <a:r>
+              <a:t>Auto-numbered agenda items</a:t>
+            </a:r>
+          </a:p>
+          <a:p>
+            <a:pPr>
+              <a:buAutoNum type="arabicPeriod"/>
+            </a:pPr>
+            <a:r>
+              <a:t>Pulled from the deck builder</a:t>
+            </a:r>
+          </a:p>
+          <a:p>
+            <a:pPr>
+              <a:buAutoNum type="arabicPeriod"/>
+            </a:pPr>
+            <a:r>
+              <a:t>Up to eight per slide</a:t>
             </a:r>
           </a:p>
         </p:txBody>
@@ -1987,7 +3044,7 @@
           <a:lstStyle/>
           <a:p>
             <a:r>
-              <a:t>Our Brands</a:t>
+              <a:t>Section Header</a:t>
             </a:r>
           </a:p>
         </p:txBody>
@@ -2007,27 +3064,8 @@
           <a:bodyPr/>
           <a:lstStyle/>
           <a:p>
-            <a:pPr/>
-            <a:r>
-              <a:t>WAC Lighting — innovative functional lighting engineered for performance and versatility</a:t>
-            </a:r>
-          </a:p>
-          <a:p>
-            <a:pPr/>
-            <a:r>
-              <a:t>WAC Architectural — purpose-built lighting systems for architectural performance</a:t>
-            </a:r>
-          </a:p>
-          <a:p>
-            <a:pPr/>
-            <a:r>
-              <a:t>Modern Forms — sleek luminaires and smart fans with integrated LED technology</a:t>
-            </a:r>
-          </a:p>
-          <a:p>
-            <a:pPr/>
-            <a:r>
-              <a:t>Schonbek — luxury chandeliers crafted from crystal and stone</a:t>
+            <a:r>
+              <a:t>Now with this subtitle line</a:t>
             </a:r>
           </a:p>
         </p:txBody>
@@ -2066,7 +3104,7 @@
           <a:lstStyle/>
           <a:p>
             <a:r>
-              <a:t>Commercial &amp; Residential</a:t>
+              <a:t>Title and Content</a:t>
             </a:r>
           </a:p>
         </p:txBody>
@@ -2087,28 +3125,19 @@
           <a:lstStyle/>
           <a:p>
             <a:r>
-              <a:t>Complete commercial lighting combining beauty, performance, and real-world support from specification to installation.</a:t>
-            </a:r>
-          </a:p>
-        </p:txBody>
-      </p:sp>
-      <p:sp>
-        <p:nvSpPr>
-          <p:cNvPr id="4" name="Text Placeholder 3"/>
-          <p:cNvSpPr>
-            <a:spLocks noGrp="1"/>
-          </p:cNvSpPr>
-          <p:nvPr>
-            <p:ph type="body" idx="2"/>
-          </p:nvPr>
-        </p:nvSpPr>
-        <p:spPr/>
-        <p:txBody>
-          <a:bodyPr/>
-          <a:lstStyle/>
-          <a:p>
-            <a:r>
-              <a:t>Sophisticated lighting for inspired living — decorative fixtures and smart fans that blend timeless design with intuitive technology.</a:t>
+              <a:t>A lead paragraph and bullets now share this content area.</a:t>
+            </a:r>
+          </a:p>
+          <a:p>
+            <a:pPr/>
+            <a:r>
+              <a:t>First point</a:t>
+            </a:r>
+          </a:p>
+          <a:p>
+            <a:pPr/>
+            <a:r>
+              <a:t>Second point</a:t>
             </a:r>
           </a:p>
         </p:txBody>
@@ -2133,39 +3162,71 @@
       <p:grpSpPr/>
       <p:sp>
         <p:nvSpPr>
-          <p:cNvPr id="2" name="Picture Placeholder 1"/>
-          <p:cNvSpPr>
-            <a:spLocks noGrp="1"/>
-          </p:cNvSpPr>
-          <p:nvPr>
-            <p:ph type="pic" idx="1"/>
+          <p:cNvPr id="2" name="Title 1"/>
+          <p:cNvSpPr>
+            <a:spLocks noGrp="1"/>
+          </p:cNvSpPr>
+          <p:nvPr>
+            <p:ph type="title"/>
           </p:nvPr>
         </p:nvSpPr>
         <p:spPr/>
+        <p:txBody>
+          <a:bodyPr/>
+          <a:lstStyle/>
+          <a:p>
+            <a:r>
+              <a:t>Title, Content and Image</a:t>
+            </a:r>
+          </a:p>
+        </p:txBody>
+      </p:sp>
+      <p:sp>
+        <p:nvSpPr>
+          <p:cNvPr id="3" name="Text Placeholder 2"/>
+          <p:cNvSpPr>
+            <a:spLocks noGrp="1"/>
+          </p:cNvSpPr>
+          <p:nvPr>
+            <p:ph type="body" idx="1"/>
+          </p:nvPr>
+        </p:nvSpPr>
+        <p:spPr/>
+        <p:txBody>
+          <a:bodyPr/>
+          <a:lstStyle/>
+          <a:p>
+            <a:pPr/>
+            <a:r>
+              <a:t>Text on the left</a:t>
+            </a:r>
+          </a:p>
+          <a:p>
+            <a:pPr/>
+            <a:r>
+              <a:t>Image on the right</a:t>
+            </a:r>
+          </a:p>
+        </p:txBody>
       </p:sp>
       <p:pic>
         <p:nvPicPr>
-          <p:cNvPr id="3" name="Picture 2" descr="demo.jpg"/>
+          <p:cNvPr id="4" name="Picture Placeholder 3" descr="i.png"/>
           <p:cNvPicPr>
-            <a:picLocks noChangeAspect="1"/>
+            <a:picLocks noGrp="1" noChangeAspect="1"/>
           </p:cNvPicPr>
-          <p:nvPr/>
+          <p:nvPr>
+            <p:ph type="pic" idx="2"/>
+          </p:nvPr>
         </p:nvPicPr>
         <p:blipFill>
           <a:blip r:embed="rId2"/>
+          <a:srcRect l="15962" r="15962"/>
           <a:stretch>
             <a:fillRect/>
           </a:stretch>
         </p:blipFill>
-        <p:spPr>
-          <a:xfrm>
-            <a:off x="0" y="0"/>
-            <a:ext cx="12192000" cy="6858000"/>
-          </a:xfrm>
-          <a:prstGeom prst="rect">
-            <a:avLst/>
-          </a:prstGeom>
-        </p:spPr>
+        <p:spPr/>
       </p:pic>
     </p:spTree>
   </p:cSld>
@@ -2185,33 +3246,35 @@
         <p:nvPr/>
       </p:nvGrpSpPr>
       <p:grpSpPr/>
-      <p:pic>
-        <p:nvPicPr>
-          <p:cNvPr id="2" name="Picture Placeholder 1" descr="demo.jpg"/>
-          <p:cNvPicPr>
-            <a:picLocks noGrp="1" noChangeAspect="1"/>
-          </p:cNvPicPr>
-          <p:nvPr>
-            <p:ph type="pic" idx="1"/>
-          </p:nvPr>
-        </p:nvPicPr>
-        <p:blipFill>
-          <a:blip r:embed="rId2"/>
-          <a:srcRect l="26250" r="26250"/>
-          <a:stretch>
-            <a:fillRect/>
-          </a:stretch>
-        </p:blipFill>
+      <p:sp>
+        <p:nvSpPr>
+          <p:cNvPr id="2" name="Title 1"/>
+          <p:cNvSpPr>
+            <a:spLocks noGrp="1"/>
+          </p:cNvSpPr>
+          <p:nvPr>
+            <p:ph type="title"/>
+          </p:nvPr>
+        </p:nvSpPr>
         <p:spPr/>
-      </p:pic>
-      <p:sp>
-        <p:nvSpPr>
-          <p:cNvPr id="3" name="Title 2"/>
-          <p:cNvSpPr>
-            <a:spLocks noGrp="1"/>
-          </p:cNvSpPr>
-          <p:nvPr>
-            <p:ph type="title"/>
+        <p:txBody>
+          <a:bodyPr/>
+          <a:lstStyle/>
+          <a:p>
+            <a:r>
+              <a:t>Two Content</a:t>
+            </a:r>
+          </a:p>
+        </p:txBody>
+      </p:sp>
+      <p:sp>
+        <p:nvSpPr>
+          <p:cNvPr id="3" name="Text Placeholder 2"/>
+          <p:cNvSpPr>
+            <a:spLocks noGrp="1"/>
+          </p:cNvSpPr>
+          <p:nvPr>
+            <p:ph type="body" idx="1"/>
           </p:nvPr>
         </p:nvSpPr>
         <p:spPr/>
@@ -2220,7 +3283,7 @@
           <a:lstStyle/>
           <a:p>
             <a:r>
-              <a:t>Sustainability at Scale</a:t>
+              <a:t>Left column copy.</a:t>
             </a:r>
           </a:p>
         </p:txBody>
@@ -2241,7 +3304,7 @@
           <a:lstStyle/>
           <a:p>
             <a:r>
-              <a:t>Our zero-emission, carbon-neutral factories set a new standard for responsible manufacturing.</a:t>
+              <a:t>Right column copy.</a:t>
             </a:r>
           </a:p>
         </p:txBody>
@@ -2266,7 +3329,80 @@
       <p:grpSpPr/>
       <p:sp>
         <p:nvSpPr>
-          <p:cNvPr id="2" name="Title 1"/>
+          <p:cNvPr id="2" name="Picture Placeholder 1"/>
+          <p:cNvSpPr>
+            <a:spLocks noGrp="1"/>
+          </p:cNvSpPr>
+          <p:nvPr>
+            <p:ph type="pic" idx="1"/>
+          </p:nvPr>
+        </p:nvSpPr>
+        <p:spPr/>
+      </p:sp>
+      <p:pic>
+        <p:nvPicPr>
+          <p:cNvPr id="3" name="Picture 2" descr="i.png"/>
+          <p:cNvPicPr>
+            <a:picLocks noChangeAspect="1"/>
+          </p:cNvPicPr>
+          <p:nvPr/>
+        </p:nvPicPr>
+        <p:blipFill>
+          <a:blip r:embed="rId2"/>
+          <a:stretch>
+            <a:fillRect/>
+          </a:stretch>
+        </p:blipFill>
+        <p:spPr>
+          <a:xfrm>
+            <a:off x="0" y="0"/>
+            <a:ext cx="12192000" cy="6858000"/>
+          </a:xfrm>
+          <a:prstGeom prst="rect">
+            <a:avLst/>
+          </a:prstGeom>
+        </p:spPr>
+      </p:pic>
+    </p:spTree>
+  </p:cSld>
+  <p:clrMapOvr>
+    <a:masterClrMapping/>
+  </p:clrMapOvr>
+</p:sld>
+</file>
+
+<file path=ppt/slides/slide8.xml><?xml version="1.0" encoding="utf-8"?>
+<p:sld xmlns:a="http://schemas.openxmlformats.org/drawingml/2006/main" xmlns:p="http://schemas.openxmlformats.org/presentationml/2006/main" xmlns:r="http://schemas.openxmlformats.org/officeDocument/2006/relationships">
+  <p:cSld>
+    <p:spTree>
+      <p:nvGrpSpPr>
+        <p:cNvPr id="1" name=""/>
+        <p:cNvGrpSpPr/>
+        <p:nvPr/>
+      </p:nvGrpSpPr>
+      <p:grpSpPr/>
+      <p:pic>
+        <p:nvPicPr>
+          <p:cNvPr id="2" name="Picture Placeholder 1" descr="i.png"/>
+          <p:cNvPicPr>
+            <a:picLocks noGrp="1" noChangeAspect="1"/>
+          </p:cNvPicPr>
+          <p:nvPr>
+            <p:ph type="pic" idx="1"/>
+          </p:nvPr>
+        </p:nvPicPr>
+        <p:blipFill>
+          <a:blip r:embed="rId2"/>
+          <a:srcRect l="26250" r="26250"/>
+          <a:stretch>
+            <a:fillRect/>
+          </a:stretch>
+        </p:blipFill>
+        <p:spPr/>
+      </p:pic>
+      <p:sp>
+        <p:nvSpPr>
+          <p:cNvPr id="3" name="Title 2"/>
           <p:cNvSpPr>
             <a:spLocks noGrp="1"/>
           </p:cNvSpPr>
@@ -2280,230 +3416,92 @@
           <a:lstStyle/>
           <a:p>
             <a:r>
-              <a:t>Brand Overview</a:t>
-            </a:r>
-          </a:p>
-        </p:txBody>
-      </p:sp>
-      <p:graphicFrame>
-        <p:nvGraphicFramePr>
-          <p:cNvPr id="3" name="Table Placeholder 2"/>
-          <p:cNvGraphicFramePr>
-            <a:graphicFrameLocks noGrp="1"/>
-          </p:cNvGraphicFramePr>
-          <p:nvPr>
-            <p:ph type="tbl" idx="1"/>
-          </p:nvPr>
-        </p:nvGraphicFramePr>
-        <p:xfrm>
-          <a:off x="548640" y="1600200"/>
-          <a:ext cx="11094720" cy="1854200"/>
-        </p:xfrm>
-        <a:graphic>
-          <a:graphicData uri="http://schemas.openxmlformats.org/drawingml/2006/table">
-            <a:tbl>
-              <a:tblPr firstRow="1" bandRow="1">
-                <a:tableStyleId>{5C22544A-7EE6-4342-B048-85BDC9FD1C3A}</a:tableStyleId>
-              </a:tblPr>
-              <a:tblGrid>
-                <a:gridCol w="3698240"/>
-                <a:gridCol w="3698240"/>
-                <a:gridCol w="3698240"/>
-              </a:tblGrid>
-              <a:tr h="370840">
-                <a:tc>
-                  <a:txBody>
-                    <a:bodyPr/>
-                    <a:lstStyle/>
-                    <a:p>
-                      <a:r>
-                        <a:t>Brand</a:t>
-                      </a:r>
-                    </a:p>
-                  </a:txBody>
-                  <a:tcPr/>
-                </a:tc>
-                <a:tc>
-                  <a:txBody>
-                    <a:bodyPr/>
-                    <a:lstStyle/>
-                    <a:p>
-                      <a:r>
-                        <a:t>Segment</a:t>
-                      </a:r>
-                    </a:p>
-                  </a:txBody>
-                  <a:tcPr/>
-                </a:tc>
-                <a:tc>
-                  <a:txBody>
-                    <a:bodyPr/>
-                    <a:lstStyle/>
-                    <a:p>
-                      <a:r>
-                        <a:t>Focus</a:t>
-                      </a:r>
-                    </a:p>
-                  </a:txBody>
-                  <a:tcPr/>
-                </a:tc>
-              </a:tr>
-              <a:tr h="370840">
-                <a:tc>
-                  <a:txBody>
-                    <a:bodyPr/>
-                    <a:lstStyle/>
-                    <a:p>
-                      <a:r>
-                        <a:t>WAC Lighting</a:t>
-                      </a:r>
-                    </a:p>
-                  </a:txBody>
-                  <a:tcPr/>
-                </a:tc>
-                <a:tc>
-                  <a:txBody>
-                    <a:bodyPr/>
-                    <a:lstStyle/>
-                    <a:p>
-                      <a:r>
-                        <a:t>Commercial + Residential</a:t>
-                      </a:r>
-                    </a:p>
-                  </a:txBody>
-                  <a:tcPr/>
-                </a:tc>
-                <a:tc>
-                  <a:txBody>
-                    <a:bodyPr/>
-                    <a:lstStyle/>
-                    <a:p>
-                      <a:r>
-                        <a:t>Functional lighting systems</a:t>
-                      </a:r>
-                    </a:p>
-                  </a:txBody>
-                  <a:tcPr/>
-                </a:tc>
-              </a:tr>
-              <a:tr h="370840">
-                <a:tc>
-                  <a:txBody>
-                    <a:bodyPr/>
-                    <a:lstStyle/>
-                    <a:p>
-                      <a:r>
-                        <a:t>WAC Architectural</a:t>
-                      </a:r>
-                    </a:p>
-                  </a:txBody>
-                  <a:tcPr/>
-                </a:tc>
-                <a:tc>
-                  <a:txBody>
-                    <a:bodyPr/>
-                    <a:lstStyle/>
-                    <a:p>
-                      <a:r>
-                        <a:t>Commercial</a:t>
-                      </a:r>
-                    </a:p>
-                  </a:txBody>
-                  <a:tcPr/>
-                </a:tc>
-                <a:tc>
-                  <a:txBody>
-                    <a:bodyPr/>
-                    <a:lstStyle/>
-                    <a:p>
-                      <a:r>
-                        <a:t>Architectural lighting systems</a:t>
-                      </a:r>
-                    </a:p>
-                  </a:txBody>
-                  <a:tcPr/>
-                </a:tc>
-              </a:tr>
-              <a:tr h="370840">
-                <a:tc>
-                  <a:txBody>
-                    <a:bodyPr/>
-                    <a:lstStyle/>
-                    <a:p>
-                      <a:r>
-                        <a:t>Modern Forms</a:t>
-                      </a:r>
-                    </a:p>
-                  </a:txBody>
-                  <a:tcPr/>
-                </a:tc>
-                <a:tc>
-                  <a:txBody>
-                    <a:bodyPr/>
-                    <a:lstStyle/>
-                    <a:p>
-                      <a:r>
-                        <a:t>Residential</a:t>
-                      </a:r>
-                    </a:p>
-                  </a:txBody>
-                  <a:tcPr/>
-                </a:tc>
-                <a:tc>
-                  <a:txBody>
-                    <a:bodyPr/>
-                    <a:lstStyle/>
-                    <a:p>
-                      <a:r>
-                        <a:t>Smart fans and luminaires</a:t>
-                      </a:r>
-                    </a:p>
-                  </a:txBody>
-                  <a:tcPr/>
-                </a:tc>
-              </a:tr>
-              <a:tr h="370840">
-                <a:tc>
-                  <a:txBody>
-                    <a:bodyPr/>
-                    <a:lstStyle/>
-                    <a:p>
-                      <a:r>
-                        <a:t>Schonbek</a:t>
-                      </a:r>
-                    </a:p>
-                  </a:txBody>
-                  <a:tcPr/>
-                </a:tc>
-                <a:tc>
-                  <a:txBody>
-                    <a:bodyPr/>
-                    <a:lstStyle/>
-                    <a:p>
-                      <a:r>
-                        <a:t>Luxury</a:t>
-                      </a:r>
-                    </a:p>
-                  </a:txBody>
-                  <a:tcPr/>
-                </a:tc>
-                <a:tc>
-                  <a:txBody>
-                    <a:bodyPr/>
-                    <a:lstStyle/>
-                    <a:p>
-                      <a:r>
-                        <a:t>Crystal chandeliers</a:t>
-                      </a:r>
-                    </a:p>
-                  </a:txBody>
-                  <a:tcPr/>
-                </a:tc>
-              </a:tr>
-            </a:tbl>
-          </a:graphicData>
-        </a:graphic>
-      </p:graphicFrame>
+              <a:t>Picture with Caption</a:t>
+            </a:r>
+          </a:p>
+        </p:txBody>
+      </p:sp>
+      <p:sp>
+        <p:nvSpPr>
+          <p:cNvPr id="4" name="Text Placeholder 3"/>
+          <p:cNvSpPr>
+            <a:spLocks noGrp="1"/>
+          </p:cNvSpPr>
+          <p:nvPr>
+            <p:ph type="body" idx="2"/>
+          </p:nvPr>
+        </p:nvSpPr>
+        <p:spPr/>
+        <p:txBody>
+          <a:bodyPr/>
+          <a:lstStyle/>
+          <a:p>
+            <a:r>
+              <a:t>Caption text under the headline</a:t>
+            </a:r>
+          </a:p>
+        </p:txBody>
+      </p:sp>
+    </p:spTree>
+  </p:cSld>
+  <p:clrMapOvr>
+    <a:masterClrMapping/>
+  </p:clrMapOvr>
+</p:sld>
+</file>
+
+<file path=ppt/slides/slide9.xml><?xml version="1.0" encoding="utf-8"?>
+<p:sld xmlns:a="http://schemas.openxmlformats.org/drawingml/2006/main" xmlns:p="http://schemas.openxmlformats.org/presentationml/2006/main" xmlns:r="http://schemas.openxmlformats.org/officeDocument/2006/relationships">
+  <p:cSld>
+    <p:spTree>
+      <p:nvGrpSpPr>
+        <p:cNvPr id="1" name=""/>
+        <p:cNvGrpSpPr/>
+        <p:nvPr/>
+      </p:nvGrpSpPr>
+      <p:grpSpPr/>
+      <p:sp>
+        <p:nvSpPr>
+          <p:cNvPr id="2" name="Text Placeholder 1"/>
+          <p:cNvSpPr>
+            <a:spLocks noGrp="1"/>
+          </p:cNvSpPr>
+          <p:nvPr>
+            <p:ph type="body" idx="1"/>
+          </p:nvPr>
+        </p:nvSpPr>
+        <p:spPr/>
+        <p:txBody>
+          <a:bodyPr/>
+          <a:lstStyle/>
+          <a:p>
+            <a:r>
+              <a:t>Lighting is the jewelry of architecture.</a:t>
+            </a:r>
+          </a:p>
+        </p:txBody>
+      </p:sp>
+      <p:sp>
+        <p:nvSpPr>
+          <p:cNvPr id="3" name="Text Placeholder 2"/>
+          <p:cNvSpPr>
+            <a:spLocks noGrp="1"/>
+          </p:cNvSpPr>
+          <p:nvPr>
+            <p:ph type="body" idx="2"/>
+          </p:nvPr>
+        </p:nvSpPr>
+        <p:spPr/>
+        <p:txBody>
+          <a:bodyPr/>
+          <a:lstStyle/>
+          <a:p>
+            <a:r>
+              <a:t>— Example attribution</a:t>
+            </a:r>
+          </a:p>
+        </p:txBody>
+      </p:sp>
     </p:spTree>
   </p:cSld>
   <p:clrMapOvr>

</xml_diff>